<commit_message>
chore: add zoho-first admin guides and assets
</commit_message>
<xml_diff>
--- a/docs/transferai-prospection/TransferAI_Presentation_Entreprise_2026-05-22.pptx
+++ b/docs/transferai-prospection/TransferAI_Presentation_Entreprise_2026-05-22.pptx
@@ -2517,7 +2517,7 @@
               </a:defRPr>
             </a:pPr>
             <a:r>
-              <a:rPr sz="2100" b="1">
+              <a:rPr lang="en-GB" sz="2100" b="1" dirty="0">
                 <a:solidFill>
                   <a:srgbClr val="10213D"/>
                 </a:solidFill>
@@ -2525,8 +2525,16 @@
                 <a:ea typeface="Aptos Display"/>
                 <a:cs typeface="Aptos Display"/>
               </a:rPr>
-              <a:t>6</a:t>
-            </a:r>
+              <a:t>5</a:t>
+            </a:r>
+            <a:endParaRPr sz="2100" b="1" dirty="0">
+              <a:solidFill>
+                <a:srgbClr val="10213D"/>
+              </a:solidFill>
+              <a:latin typeface="Aptos Display"/>
+              <a:ea typeface="Aptos Display"/>
+              <a:cs typeface="Aptos Display"/>
+            </a:endParaRPr>
           </a:p>
         </p:txBody>
       </p:sp>
@@ -4459,7 +4467,7 @@
         </p:nvSpPr>
         <p:spPr>
           <a:xfrm>
-            <a:off x="0" y="0"/>
+            <a:off x="0" y="184150"/>
             <a:ext cx="12192000" cy="6858000"/>
           </a:xfrm>
           <a:prstGeom prst="rect">
@@ -5469,7 +5477,7 @@
         </p:nvSpPr>
         <p:spPr>
           <a:xfrm>
-            <a:off x="2381250" y="5676900"/>
+            <a:off x="2785534" y="5701242"/>
             <a:ext cx="1543050" cy="571500"/>
           </a:xfrm>
           <a:prstGeom prst="rect">
@@ -5500,7 +5508,7 @@
         </p:blipFill>
         <p:spPr>
           <a:xfrm>
-            <a:off x="2895600" y="5791200"/>
+            <a:off x="3242734" y="5791200"/>
             <a:ext cx="514350" cy="342900"/>
           </a:xfrm>
           <a:prstGeom prst="rect">
@@ -5510,61 +5518,6 @@
       </p:pic>
       <p:sp>
         <p:nvSpPr>
-          <p:cNvPr id="23" name="Rectangle 22">
-            <a:extLst>
-              <a:ext uri="{FF2B5EF4-FFF2-40B4-BE49-F238E27FC236}">
-                <a16:creationId xmlns:a16="http://schemas.microsoft.com/office/drawing/2014/main" id="{E2D64FFD-1291-4E2C-B2DF-0AA938765782}"/>
-              </a:ext>
-            </a:extLst>
-          </p:cNvPr>
-          <p:cNvSpPr>
-            <a:spLocks noGrp="1"/>
-          </p:cNvSpPr>
-          <p:nvPr/>
-        </p:nvSpPr>
-        <p:spPr>
-          <a:xfrm>
-            <a:off x="4191000" y="5676900"/>
-            <a:ext cx="1543050" cy="571500"/>
-          </a:xfrm>
-          <a:prstGeom prst="rect">
-            <a:avLst/>
-          </a:prstGeom>
-          <a:solidFill>
-            <a:srgbClr val="FFFDFC"/>
-          </a:solidFill>
-          <a:ln w="9525">
-            <a:solidFill>
-              <a:srgbClr val="D9D3CC"/>
-            </a:solidFill>
-            <a:prstDash val="solid"/>
-          </a:ln>
-        </p:spPr>
-      </p:sp>
-      <p:pic>
-        <p:nvPicPr>
-          <p:cNvPr id="24" name="Picture 23"/>
-          <p:cNvPicPr>
-            <a:picLocks noChangeAspect="1"/>
-          </p:cNvPicPr>
-          <p:nvPr/>
-        </p:nvPicPr>
-        <p:blipFill>
-          <a:blip r:embed="rId6"/>
-          <a:stretch/>
-        </p:blipFill>
-        <p:spPr>
-          <a:xfrm>
-            <a:off x="4705350" y="5791200"/>
-            <a:ext cx="514350" cy="342900"/>
-          </a:xfrm>
-          <a:prstGeom prst="rect">
-            <a:avLst/>
-          </a:prstGeom>
-        </p:spPr>
-      </p:pic>
-      <p:sp>
-        <p:nvSpPr>
           <p:cNvPr id="25" name="Rectangle 24">
             <a:extLst>
               <a:ext uri="{FF2B5EF4-FFF2-40B4-BE49-F238E27FC236}">
@@ -5579,7 +5532,7 @@
         </p:nvSpPr>
         <p:spPr>
           <a:xfrm>
-            <a:off x="6000750" y="5676900"/>
+            <a:off x="5238750" y="5701242"/>
             <a:ext cx="1543050" cy="571500"/>
           </a:xfrm>
           <a:prstGeom prst="rect">
@@ -5605,12 +5558,12 @@
           <p:nvPr/>
         </p:nvPicPr>
         <p:blipFill>
-          <a:blip r:embed="rId7"/>
+          <a:blip r:embed="rId6"/>
           <a:stretch/>
         </p:blipFill>
         <p:spPr>
           <a:xfrm>
-            <a:off x="6600825" y="5791200"/>
+            <a:off x="5804954" y="5791200"/>
             <a:ext cx="342900" cy="342900"/>
           </a:xfrm>
           <a:prstGeom prst="rect">
@@ -5634,7 +5587,7 @@
         </p:nvSpPr>
         <p:spPr>
           <a:xfrm>
-            <a:off x="7810500" y="5676900"/>
+            <a:off x="7648575" y="5673725"/>
             <a:ext cx="1543050" cy="571500"/>
           </a:xfrm>
           <a:prstGeom prst="rect">
@@ -5660,12 +5613,12 @@
           <p:nvPr/>
         </p:nvPicPr>
         <p:blipFill>
-          <a:blip r:embed="rId8"/>
+          <a:blip r:embed="rId7"/>
           <a:stretch/>
         </p:blipFill>
         <p:spPr>
           <a:xfrm>
-            <a:off x="8410575" y="5791200"/>
+            <a:off x="8232768" y="5791200"/>
             <a:ext cx="342900" cy="342900"/>
           </a:xfrm>
           <a:prstGeom prst="rect">
@@ -5715,7 +5668,7 @@
           <p:nvPr/>
         </p:nvPicPr>
         <p:blipFill>
-          <a:blip r:embed="rId9"/>
+          <a:blip r:embed="rId8"/>
           <a:stretch/>
         </p:blipFill>
         <p:spPr>
@@ -16657,7 +16610,7 @@
         </p:nvSpPr>
         <p:spPr>
           <a:xfrm>
-            <a:off x="0" y="0"/>
+            <a:off x="0" y="190500"/>
             <a:ext cx="12192000" cy="6858000"/>
           </a:xfrm>
           <a:prstGeom prst="rect">
@@ -17129,8 +17082,8 @@
         </p:nvSpPr>
         <p:spPr>
           <a:xfrm>
-            <a:off x="857250" y="4838700"/>
-            <a:ext cx="4381500" cy="190500"/>
+            <a:off x="857250" y="4876800"/>
+            <a:ext cx="5372100" cy="152400"/>
           </a:xfrm>
           <a:prstGeom prst="rect">
             <a:avLst/>
@@ -17164,7 +17117,7 @@
               </a:defRPr>
             </a:pPr>
             <a:r>
-              <a:rPr sz="1125" b="1">
+              <a:rPr sz="1125" b="1" dirty="0">
                 <a:solidFill>
                   <a:srgbClr val="FFFFFF"/>
                 </a:solidFill>
@@ -17172,7 +17125,95 @@
                 <a:ea typeface="Aptos"/>
                 <a:cs typeface="Aptos"/>
               </a:rPr>
-              <a:t>3. Recevoir une première orientation : formation, accompagnement ou solution</a:t>
+              <a:t>3. </a:t>
+            </a:r>
+            <a:r>
+              <a:rPr sz="1125" b="1" dirty="0" err="1">
+                <a:solidFill>
+                  <a:srgbClr val="FFFFFF"/>
+                </a:solidFill>
+                <a:latin typeface="Aptos"/>
+                <a:ea typeface="Aptos"/>
+                <a:cs typeface="Aptos"/>
+              </a:rPr>
+              <a:t>Recevoir</a:t>
+            </a:r>
+            <a:r>
+              <a:rPr sz="1125" b="1" dirty="0">
+                <a:solidFill>
+                  <a:srgbClr val="FFFFFF"/>
+                </a:solidFill>
+                <a:latin typeface="Aptos"/>
+                <a:ea typeface="Aptos"/>
+                <a:cs typeface="Aptos"/>
+              </a:rPr>
+              <a:t> </a:t>
+            </a:r>
+            <a:r>
+              <a:rPr sz="1125" b="1" dirty="0" err="1">
+                <a:solidFill>
+                  <a:srgbClr val="FFFFFF"/>
+                </a:solidFill>
+                <a:latin typeface="Aptos"/>
+                <a:ea typeface="Aptos"/>
+                <a:cs typeface="Aptos"/>
+              </a:rPr>
+              <a:t>une</a:t>
+            </a:r>
+            <a:r>
+              <a:rPr sz="1125" b="1" dirty="0">
+                <a:solidFill>
+                  <a:srgbClr val="FFFFFF"/>
+                </a:solidFill>
+                <a:latin typeface="Aptos"/>
+                <a:ea typeface="Aptos"/>
+                <a:cs typeface="Aptos"/>
+              </a:rPr>
+              <a:t> première orientation : formation, </a:t>
+            </a:r>
+            <a:r>
+              <a:rPr sz="1125" b="1" dirty="0" err="1">
+                <a:solidFill>
+                  <a:srgbClr val="FFFFFF"/>
+                </a:solidFill>
+                <a:latin typeface="Aptos"/>
+                <a:ea typeface="Aptos"/>
+                <a:cs typeface="Aptos"/>
+              </a:rPr>
+              <a:t>accompagnement</a:t>
+            </a:r>
+            <a:r>
+              <a:rPr sz="1125" b="1" dirty="0">
+                <a:solidFill>
+                  <a:srgbClr val="FFFFFF"/>
+                </a:solidFill>
+                <a:latin typeface="Aptos"/>
+                <a:ea typeface="Aptos"/>
+                <a:cs typeface="Aptos"/>
+              </a:rPr>
+              <a:t> </a:t>
+            </a:r>
+            <a:r>
+              <a:rPr sz="1125" b="1" dirty="0" err="1">
+                <a:solidFill>
+                  <a:srgbClr val="FFFFFF"/>
+                </a:solidFill>
+                <a:latin typeface="Aptos"/>
+                <a:ea typeface="Aptos"/>
+                <a:cs typeface="Aptos"/>
+              </a:rPr>
+              <a:t>ou</a:t>
+            </a:r>
+            <a:r>
+              <a:rPr sz="1125" b="1" dirty="0">
+                <a:solidFill>
+                  <a:srgbClr val="FFFFFF"/>
+                </a:solidFill>
+                <a:latin typeface="Aptos"/>
+                <a:ea typeface="Aptos"/>
+                <a:cs typeface="Aptos"/>
+              </a:rPr>
+              <a:t> solution</a:t>
             </a:r>
           </a:p>
         </p:txBody>

</xml_diff>